<commit_message>
Integrate case studies and pharmacokinetics alternatives into main guide, PPTX, and HTML slide deck
</commit_message>
<xml_diff>
--- a/運動員中藥運動禁藥防範指南_簡報.pptx
+++ b/運動員中藥運動禁藥防範指南_簡報.pptx
@@ -3198,8 +3198,8 @@
                 </a:solidFill>
                 <a:latin typeface="Microsoft JhengHei"/>
               </a:rPr>
-              <a:t>運動員的黃金防禦與避雷指引
-傳統中藥材與科學中藥的 WADA 禁藥風險防範對策</a:t>
+              <a:t>運動員的黃金防護與避雷指引
+2026 WADA/CTADA 規範 ─ 案例融合與安全替代方案</a:t>
             </a:r>
           </a:p>
           <a:p>
@@ -3210,7 +3210,7 @@
                 </a:solidFill>
                 <a:latin typeface="Microsoft JhengHei"/>
               </a:rPr>
-              <a:t>2026 最新反運動禁藥規範對照指引</a:t>
+              <a:t>中華運動禁藥防制基金會規範對照</a:t>
             </a:r>
           </a:p>
         </p:txBody>
@@ -4010,7 +4010,7 @@
                 </a:solidFill>
                 <a:latin typeface="Microsoft JhengHei"/>
               </a:rPr>
-              <a:t>面對跌打損傷、韌帶拉傷或慢性關節痠痛，選手常用口服複方（如獨活寄生湯、疏經活血湯）或外敷麝香膏以達到祛風通絡、消炎退腫效果。</a:t>
+              <a:t>面對跌打損傷、韌帶拉傷或慢性關節痠痛，選手常用口服複方（如獨活寄生湯、疏經活血湯）或外貼麝香膏以達到祛風通絡、消炎退腫效果。</a:t>
             </a:r>
           </a:p>
         </p:txBody>
@@ -4264,8 +4264,8 @@
         </p:nvSpPr>
         <p:spPr>
           <a:xfrm>
-            <a:off x="914400" y="1645920"/>
-            <a:ext cx="4572000" cy="1645920"/>
+            <a:off x="914400" y="1371600"/>
+            <a:ext cx="4572000" cy="1097280"/>
           </a:xfrm>
           <a:prstGeom prst="rect">
             <a:avLst/>
@@ -4279,7 +4279,7 @@
           <a:lstStyle/>
           <a:p>
             <a:r>
-              <a:rPr sz="6400" b="1">
+              <a:rPr sz="5600" b="1">
                 <a:solidFill>
                   <a:srgbClr val="E63946"/>
                 </a:solidFill>
@@ -4290,7 +4290,7 @@
           </a:p>
           <a:p>
             <a:r>
-              <a:rPr sz="1600" b="1">
+              <a:rPr sz="1400" b="1">
                 <a:solidFill>
                   <a:srgbClr val="1A202C"/>
                 </a:solidFill>
@@ -4309,8 +4309,8 @@
         </p:nvSpPr>
         <p:spPr>
           <a:xfrm>
-            <a:off x="914400" y="3383280"/>
-            <a:ext cx="4572000" cy="2560320"/>
+            <a:off x="914400" y="2651760"/>
+            <a:ext cx="4572000" cy="2011680"/>
           </a:xfrm>
           <a:prstGeom prst="roundRect">
             <a:avLst/>
@@ -4354,8 +4354,191 @@
         </p:nvSpPr>
         <p:spPr>
           <a:xfrm>
-            <a:off x="1051560" y="3520440"/>
-            <a:ext cx="4297680" cy="2286000"/>
+            <a:off x="1051560" y="2743200"/>
+            <a:ext cx="4297680" cy="1828800"/>
+          </a:xfrm>
+          <a:prstGeom prst="rect">
+            <a:avLst/>
+          </a:prstGeom>
+          <a:noFill/>
+        </p:spPr>
+        <p:txBody>
+          <a:bodyPr wrap="square">
+            <a:spAutoFit/>
+          </a:bodyPr>
+          <a:lstStyle/>
+          <a:p>
+            <a:r>
+              <a:rPr sz="1400" b="1">
+                <a:solidFill>
+                  <a:srgbClr val="005F73"/>
+                </a:solidFill>
+                <a:latin typeface="Microsoft JhengHei"/>
+              </a:rPr>
+              <a:t>💡 數據實體化對比 (Real-world Analogy)
+</a:t>
+            </a:r>
+          </a:p>
+          <a:p>
+            <a:pPr>
+              <a:spcBef>
+                <a:spcPts val="400"/>
+              </a:spcBef>
+            </a:pPr>
+            <a:r>
+              <a:rPr sz="1300">
+                <a:solidFill>
+                  <a:srgbClr val="1A202C"/>
+                </a:solidFill>
+                <a:latin typeface="Microsoft JhengHei"/>
+              </a:rPr>
+              <a:t>相當於在一個 </a:t>
+            </a:r>
+            <a:r>
+              <a:rPr sz="1300" b="1">
+                <a:solidFill>
+                  <a:srgbClr val="005F73"/>
+                </a:solidFill>
+                <a:latin typeface="Microsoft JhengHei"/>
+              </a:rPr>
+              <a:t>250 萬公升標準奧運泳池</a:t>
+            </a:r>
+            <a:r>
+              <a:rPr sz="1300">
+                <a:solidFill>
+                  <a:srgbClr val="1A202C"/>
+                </a:solidFill>
+                <a:latin typeface="Microsoft JhengHei"/>
+              </a:rPr>
+              <a:t>中，只滴入 </a:t>
+            </a:r>
+            <a:r>
+              <a:rPr sz="1300" b="1">
+                <a:solidFill>
+                  <a:srgbClr val="E63946"/>
+                </a:solidFill>
+                <a:latin typeface="Microsoft JhengHei"/>
+              </a:rPr>
+              <a:t>0.025 毫升（半滴水）</a:t>
+            </a:r>
+            <a:r>
+              <a:rPr sz="1300">
+                <a:solidFill>
+                  <a:srgbClr val="1A202C"/>
+                </a:solidFill>
+                <a:latin typeface="Microsoft JhengHei"/>
+              </a:rPr>
+              <a:t>的禁用藥物。運動員喝一杯「蓮子心茶」即會嚴重超標。</a:t>
+            </a:r>
+          </a:p>
+        </p:txBody>
+      </p:sp>
+      <p:sp>
+        <p:nvSpPr>
+          <p:cNvPr id="7" name="Rounded Rectangle 6"/>
+          <p:cNvSpPr/>
+          <p:nvPr/>
+        </p:nvSpPr>
+        <p:spPr>
+          <a:xfrm>
+            <a:off x="914400" y="4846320"/>
+            <a:ext cx="4572000" cy="1463040"/>
+          </a:xfrm>
+          <a:prstGeom prst="roundRect">
+            <a:avLst/>
+          </a:prstGeom>
+          <a:solidFill>
+            <a:srgbClr val="FED7D7"/>
+          </a:solidFill>
+          <a:ln w="15240">
+            <a:solidFill>
+              <a:srgbClr val="E63946"/>
+            </a:solidFill>
+          </a:ln>
+        </p:spPr>
+        <p:style>
+          <a:lnRef idx="1">
+            <a:schemeClr val="accent1"/>
+          </a:lnRef>
+          <a:fillRef idx="3">
+            <a:schemeClr val="accent1"/>
+          </a:fillRef>
+          <a:effectRef idx="2">
+            <a:schemeClr val="accent1"/>
+          </a:effectRef>
+          <a:fontRef idx="minor">
+            <a:schemeClr val="lt1"/>
+          </a:fontRef>
+        </p:style>
+        <p:txBody>
+          <a:bodyPr rtlCol="0" anchor="ctr"/>
+          <a:lstStyle/>
+          <a:p>
+            <a:pPr algn="ctr"/>
+          </a:p>
+        </p:txBody>
+      </p:sp>
+      <p:sp>
+        <p:nvSpPr>
+          <p:cNvPr id="8" name="TextBox 7"/>
+          <p:cNvSpPr txBox="1"/>
+          <p:nvPr/>
+        </p:nvSpPr>
+        <p:spPr>
+          <a:xfrm>
+            <a:off x="1051560" y="4937760"/>
+            <a:ext cx="4297680" cy="1280160"/>
+          </a:xfrm>
+          <a:prstGeom prst="rect">
+            <a:avLst/>
+          </a:prstGeom>
+          <a:noFill/>
+        </p:spPr>
+        <p:txBody>
+          <a:bodyPr wrap="square">
+            <a:spAutoFit/>
+          </a:bodyPr>
+          <a:lstStyle/>
+          <a:p>
+            <a:r>
+              <a:rPr sz="1300" b="1">
+                <a:solidFill>
+                  <a:srgbClr val="E63946"/>
+                </a:solidFill>
+                <a:latin typeface="Microsoft JhengHei"/>
+              </a:rPr>
+              <a:t>🚨 去甲烏藥鹼 ─ 真實禁賽案例</a:t>
+            </a:r>
+          </a:p>
+          <a:p>
+            <a:pPr>
+              <a:spcBef>
+                <a:spcPts val="200"/>
+              </a:spcBef>
+            </a:pPr>
+            <a:r>
+              <a:rPr sz="1150">
+                <a:solidFill>
+                  <a:srgbClr val="1A202C"/>
+                </a:solidFill>
+                <a:latin typeface="Microsoft JhengHei"/>
+              </a:rPr>
+              <a:t>• 香港鉛球選手杜婉筠 (2022) 因賽前服用中藥鋪調配的草藥調理，檢出 Higenamine，被重罰禁賽 2 年。
+• 肯亞選手 Philip (2019) 因生病服用了母親熬煮的草藥茶，同樣被判禁賽 2 年。民俗療法無免責空間。</a:t>
+            </a:r>
+          </a:p>
+        </p:txBody>
+      </p:sp>
+      <p:sp>
+        <p:nvSpPr>
+          <p:cNvPr id="9" name="TextBox 8"/>
+          <p:cNvSpPr txBox="1"/>
+          <p:nvPr/>
+        </p:nvSpPr>
+        <p:spPr>
+          <a:xfrm>
+            <a:off x="5852160" y="1371600"/>
+            <a:ext cx="5394960" cy="4937760"/>
           </a:xfrm>
           <a:prstGeom prst="rect">
             <a:avLst/>
@@ -4374,222 +4557,136 @@
               </a:spcAft>
             </a:pPr>
             <a:r>
-              <a:rPr sz="1600" b="1">
-                <a:solidFill>
-                  <a:srgbClr val="005F73"/>
-                </a:solidFill>
-                <a:latin typeface="Microsoft JhengHei"/>
-              </a:rPr>
-              <a:t>💡 數據實體化對比 (Real-world Analogy)</a:t>
-            </a:r>
-          </a:p>
-          <a:p>
-            <a:r>
-              <a:rPr sz="1400">
-                <a:solidFill>
-                  <a:srgbClr val="1A202C"/>
-                </a:solidFill>
-                <a:latin typeface="Microsoft JhengHei"/>
-              </a:rPr>
-              <a:t>去甲烏藥鹼的檢測限制極為嚴格。10 ng/mL 相當於在一座容量為 </a:t>
-            </a:r>
-            <a:r>
-              <a:rPr sz="1400" b="1">
-                <a:solidFill>
-                  <a:srgbClr val="005F73"/>
-                </a:solidFill>
-                <a:latin typeface="Microsoft JhengHei"/>
-              </a:rPr>
-              <a:t>250 萬公升的標準奧運游泳池</a:t>
-            </a:r>
-            <a:r>
-              <a:rPr sz="1400">
-                <a:solidFill>
-                  <a:srgbClr val="1A202C"/>
-                </a:solidFill>
-                <a:latin typeface="Microsoft JhengHei"/>
-              </a:rPr>
-              <a:t>中，只滴入 </a:t>
-            </a:r>
-            <a:r>
-              <a:rPr sz="1400" b="1">
+              <a:rPr sz="1800" b="1">
                 <a:solidFill>
                   <a:srgbClr val="E63946"/>
                 </a:solidFill>
                 <a:latin typeface="Microsoft JhengHei"/>
               </a:rPr>
-              <a:t>0.025 毫升（約半滴）</a:t>
-            </a:r>
-            <a:r>
-              <a:rPr sz="1400">
-                <a:solidFill>
-                  <a:srgbClr val="1A202C"/>
-                </a:solidFill>
-                <a:latin typeface="Microsoft JhengHei"/>
-              </a:rPr>
-              <a:t>的純化成分。運動員只要喝下一杯天然「蓮子心茶」，幾小時內就會引發尿檢陽性。</a:t>
-            </a:r>
-          </a:p>
-        </p:txBody>
-      </p:sp>
-      <p:sp>
-        <p:nvSpPr>
-          <p:cNvPr id="7" name="TextBox 6"/>
-          <p:cNvSpPr txBox="1"/>
-          <p:nvPr/>
-        </p:nvSpPr>
-        <p:spPr>
-          <a:xfrm>
-            <a:off x="5943600" y="1645920"/>
-            <a:ext cx="5303520" cy="4297680"/>
-          </a:xfrm>
-          <a:prstGeom prst="rect">
-            <a:avLst/>
-          </a:prstGeom>
-          <a:noFill/>
-        </p:spPr>
-        <p:txBody>
-          <a:bodyPr wrap="square">
-            <a:spAutoFit/>
-          </a:bodyPr>
-          <a:lstStyle/>
+              <a:t>❌ 禁用成分之天然中藥來源</a:t>
+            </a:r>
+          </a:p>
           <a:p>
             <a:pPr>
               <a:spcAft>
-                <a:spcPts val="1000"/>
+                <a:spcPts val="600"/>
               </a:spcAft>
             </a:pPr>
             <a:r>
-              <a:rPr sz="1800" b="1">
-                <a:solidFill>
-                  <a:srgbClr val="E63946"/>
-                </a:solidFill>
-                <a:latin typeface="Microsoft JhengHei"/>
-              </a:rPr>
-              <a:t>❌ 含有去甲烏藥鹼的高風險來源</a:t>
+              <a:rPr sz="1350" b="1">
+                <a:solidFill>
+                  <a:srgbClr val="1A202C"/>
+                </a:solidFill>
+                <a:latin typeface="Microsoft JhengHei"/>
+              </a:rPr>
+              <a:t>• 蓮子心：</a:t>
+            </a:r>
+            <a:r>
+              <a:rPr sz="1350">
+                <a:solidFill>
+                  <a:srgbClr val="4A5568"/>
+                </a:solidFill>
+                <a:latin typeface="Microsoft JhengHei"/>
+              </a:rPr>
+              <a:t>含量極高。常用於降火助眠，運動員賽前絕對禁止飲用。</a:t>
             </a:r>
           </a:p>
           <a:p>
             <a:pPr>
+              <a:spcAft>
+                <a:spcPts val="600"/>
+              </a:spcAft>
+            </a:pPr>
+            <a:r>
+              <a:rPr sz="1350" b="1">
+                <a:solidFill>
+                  <a:srgbClr val="1A202C"/>
+                </a:solidFill>
+                <a:latin typeface="Microsoft JhengHei"/>
+              </a:rPr>
+              <a:t>• 附子、細辛、吳茱萸：</a:t>
+            </a:r>
+            <a:r>
+              <a:rPr sz="1350">
+                <a:solidFill>
+                  <a:srgbClr val="4A5568"/>
+                </a:solidFill>
+                <a:latin typeface="Microsoft JhengHei"/>
+              </a:rPr>
+              <a:t>常見中藥，廣泛存在於溫陽祛寒方劑中。</a:t>
+            </a:r>
+          </a:p>
+          <a:p>
+            <a:pPr>
+              <a:spcAft>
+                <a:spcPts val="600"/>
+              </a:spcAft>
+            </a:pPr>
+            <a:r>
+              <a:rPr sz="1350" b="1">
+                <a:solidFill>
+                  <a:srgbClr val="1A202C"/>
+                </a:solidFill>
+                <a:latin typeface="Microsoft JhengHei"/>
+              </a:rPr>
+              <a:t>• 日常水果：</a:t>
+            </a:r>
+            <a:r>
+              <a:rPr sz="1350">
+                <a:solidFill>
+                  <a:srgbClr val="4A5568"/>
+                </a:solidFill>
+                <a:latin typeface="Microsoft JhengHei"/>
+              </a:rPr>
+              <a:t>釋迦亦含有天然去甲烏藥鹼，賽前應避免大量食用。</a:t>
+            </a:r>
+          </a:p>
+          <a:p>
+            <a:pPr>
+              <a:spcBef>
+                <a:spcPts val="1200"/>
+              </a:spcBef>
               <a:spcAft>
                 <a:spcPts val="800"/>
               </a:spcAft>
             </a:pPr>
             <a:r>
-              <a:rPr sz="1400" b="1">
-                <a:solidFill>
-                  <a:srgbClr val="1A202C"/>
-                </a:solidFill>
-                <a:latin typeface="Microsoft JhengHei"/>
-              </a:rPr>
-              <a:t>• 蓮子心：</a:t>
-            </a:r>
-            <a:r>
-              <a:rPr sz="1400">
+              <a:rPr sz="1700" b="1">
+                <a:solidFill>
+                  <a:srgbClr val="005F73"/>
+                </a:solidFill>
+                <a:latin typeface="Microsoft JhengHei"/>
+              </a:rPr>
+              <a:t>⚠️ 隱藏前驅物代謝風險：烏藥鹼 (Coclaurine)</a:t>
+            </a:r>
+          </a:p>
+          <a:p>
+            <a:r>
+              <a:rPr sz="1350">
                 <a:solidFill>
                   <a:srgbClr val="4A5568"/>
                 </a:solidFill>
                 <a:latin typeface="Microsoft JhengHei"/>
               </a:rPr>
-              <a:t>含量居冠。常用於降火、助眠，運動員賽前應絕對禁止飲用。</a:t>
-            </a:r>
-          </a:p>
-          <a:p>
-            <a:pPr>
-              <a:spcAft>
-                <a:spcPts val="800"/>
-              </a:spcAft>
-            </a:pPr>
-            <a:r>
-              <a:rPr sz="1400" b="1">
-                <a:solidFill>
-                  <a:srgbClr val="1A202C"/>
-                </a:solidFill>
-                <a:latin typeface="Microsoft JhengHei"/>
-              </a:rPr>
-              <a:t>• 附子、細辛、吳茱萸：</a:t>
-            </a:r>
-            <a:r>
-              <a:rPr sz="1400">
+              <a:t>Coclaurine 本身未禁用，但在人體內會脫甲基代謝轉化為去甲烏藥鹼。富含於</a:t>
+            </a:r>
+            <a:r>
+              <a:rPr sz="1350" b="1">
+                <a:solidFill>
+                  <a:srgbClr val="E63946"/>
+                </a:solidFill>
+                <a:latin typeface="Microsoft JhengHei"/>
+              </a:rPr>
+              <a:t>肉桂、大棗、黃柏</a:t>
+            </a:r>
+            <a:r>
+              <a:rPr sz="1350">
                 <a:solidFill>
                   <a:srgbClr val="4A5568"/>
                 </a:solidFill>
                 <a:latin typeface="Microsoft JhengHei"/>
               </a:rPr>
-              <a:t>常見中藥材，廣泛存在於溫陽祛寒方劑（如四逆湯）中。</a:t>
-            </a:r>
-          </a:p>
-          <a:p>
-            <a:pPr>
-              <a:spcAft>
-                <a:spcPts val="800"/>
-              </a:spcAft>
-            </a:pPr>
-            <a:r>
-              <a:rPr sz="1400" b="1">
-                <a:solidFill>
-                  <a:srgbClr val="1A202C"/>
-                </a:solidFill>
-                <a:latin typeface="Microsoft JhengHei"/>
-              </a:rPr>
-              <a:t>• 日常水果風險：</a:t>
-            </a:r>
-            <a:r>
-              <a:rPr sz="1400">
-                <a:solidFill>
-                  <a:srgbClr val="4A5568"/>
-                </a:solidFill>
-                <a:latin typeface="Microsoft JhengHei"/>
-              </a:rPr>
-              <a:t>釋迦（番荔枝科）含有天然去甲烏藥鹼，臨賽期應避免大量食用。</a:t>
-            </a:r>
-          </a:p>
-          <a:p>
-            <a:pPr>
-              <a:spcBef>
-                <a:spcPts val="1400"/>
-              </a:spcBef>
-              <a:spcAft>
-                <a:spcPts val="1000"/>
-              </a:spcAft>
-            </a:pPr>
-            <a:r>
-              <a:rPr sz="1800" b="1">
-                <a:solidFill>
-                  <a:srgbClr val="005F73"/>
-                </a:solidFill>
-                <a:latin typeface="Microsoft JhengHei"/>
-              </a:rPr>
-              <a:t>⚠️ 隱藏前驅物風險 ─ 烏藥鹼 (Coclaurine)</a:t>
-            </a:r>
-          </a:p>
-          <a:p>
-            <a:r>
-              <a:rPr sz="1400">
-                <a:solidFill>
-                  <a:srgbClr val="4A5568"/>
-                </a:solidFill>
-                <a:latin typeface="Microsoft JhengHei"/>
-              </a:rPr>
-              <a:t>最新藥物動力學發現，Coclaurine 本身未被禁用，但口服後會在人體內脫甲基代謝轉化為 </a:t>
-            </a:r>
-            <a:r>
-              <a:rPr sz="1400" b="1">
-                <a:solidFill>
-                  <a:srgbClr val="E63946"/>
-                </a:solidFill>
-                <a:latin typeface="Microsoft JhengHei"/>
-              </a:rPr>
-              <a:t>Higenamine</a:t>
-            </a:r>
-            <a:r>
-              <a:rPr sz="1400">
-                <a:solidFill>
-                  <a:srgbClr val="4A5568"/>
-                </a:solidFill>
-                <a:latin typeface="Microsoft JhengHei"/>
-              </a:rPr>
-              <a:t>。常見中草藥如肉桂、大棗、黃柏等均富含此成分，使避雷難度大增。</a:t>
+              <a:t>中。這使得葛根湯、十全大補湯等常見含有大棗與肉桂的複方，避雷難度顯著增加。</a:t>
             </a:r>
           </a:p>
         </p:txBody>
@@ -4716,8 +4813,8 @@
         </p:nvSpPr>
         <p:spPr>
           <a:xfrm>
-            <a:off x="914400" y="1645920"/>
-            <a:ext cx="4114800" cy="4572000"/>
+            <a:off x="914400" y="1371600"/>
+            <a:ext cx="4114800" cy="2926080"/>
           </a:xfrm>
           <a:prstGeom prst="rect">
             <a:avLst/>
@@ -4731,7 +4828,7 @@
           <a:lstStyle/>
           <a:p>
             <a:r>
-              <a:rPr sz="5400" b="1">
+              <a:rPr sz="4800" b="1">
                 <a:solidFill>
                   <a:srgbClr val="E63946"/>
                 </a:solidFill>
@@ -4741,62 +4838,157 @@
 </a:t>
             </a:r>
             <a:r>
-              <a:rPr sz="1400" b="1">
+              <a:rPr sz="1300" b="1">
                 <a:solidFill>
                   <a:srgbClr val="1A202C"/>
                 </a:solidFill>
                 <a:latin typeface="Microsoft JhengHei"/>
               </a:rPr>
-              <a:t>WADA 麻黃鹼尿液檢測判定陽性閾值</a:t>
+              <a:t>WADA 麻黃鹼尿檢判定陽性閾值
+</a:t>
             </a:r>
           </a:p>
           <a:p>
             <a:pPr>
               <a:spcBef>
-                <a:spcPts val="1400"/>
+                <a:spcPts val="400"/>
               </a:spcBef>
             </a:pPr>
             <a:r>
-              <a:rPr sz="1400">
+              <a:rPr sz="1200">
                 <a:solidFill>
                   <a:srgbClr val="4A5568"/>
                 </a:solidFill>
                 <a:latin typeface="Microsoft JhengHei"/>
               </a:rPr>
-              <a:t>⚠️ 累積效應的「溫水煮青蛙」：
-科學中藥（如葛根湯、小青龍湯）單次服用時，尿液濃度均在安全閾值內；然而若連續服用 </a:t>
-            </a:r>
-            <a:r>
-              <a:rPr sz="1400" b="1">
+              <a:t>⚠️ 藥物在體內具有蓄積半衰期。單次服用（2.5g 科學中藥）後濃度低於門檻，但若連續服用 3 天（一日三次），尿中麻黃鹼濃度會飆升，高機率超標判定違規。此外，當尿液呈</a:t>
+            </a:r>
+            <a:r>
+              <a:rPr sz="1200" b="1">
                 <a:solidFill>
                   <a:srgbClr val="E63946"/>
                 </a:solidFill>
                 <a:latin typeface="Microsoft JhengHei"/>
               </a:rPr>
-              <a:t>3 天（一日三次）</a:t>
-            </a:r>
-            <a:r>
-              <a:rPr sz="1400">
+              <a:t>鹼性 (pH &gt; 7.0)</a:t>
+            </a:r>
+            <a:r>
+              <a:rPr sz="1200">
                 <a:solidFill>
                   <a:srgbClr val="4A5568"/>
                 </a:solidFill>
                 <a:latin typeface="Microsoft JhengHei"/>
               </a:rPr>
-              <a:t>，體內藥物累積將導致排泄濃度呈倍數飆升，觸發陽性判定。</a:t>
-            </a:r>
-          </a:p>
-        </p:txBody>
-      </p:sp>
-      <p:sp>
-        <p:nvSpPr>
-          <p:cNvPr id="5" name="Rectangle 4"/>
+              <a:t>時，排泄速度減慢，會大幅延長超標風險期。</a:t>
+            </a:r>
+          </a:p>
+        </p:txBody>
+      </p:sp>
+      <p:sp>
+        <p:nvSpPr>
+          <p:cNvPr id="5" name="Rounded Rectangle 4"/>
           <p:cNvSpPr/>
           <p:nvPr/>
         </p:nvSpPr>
         <p:spPr>
           <a:xfrm>
-            <a:off x="6675120" y="1645920"/>
-            <a:ext cx="36576" cy="4114800"/>
+            <a:off x="914400" y="4389120"/>
+            <a:ext cx="4114800" cy="1920240"/>
+          </a:xfrm>
+          <a:prstGeom prst="roundRect">
+            <a:avLst/>
+          </a:prstGeom>
+          <a:solidFill>
+            <a:srgbClr val="FED7D7"/>
+          </a:solidFill>
+          <a:ln w="15240">
+            <a:solidFill>
+              <a:srgbClr val="E63946"/>
+            </a:solidFill>
+          </a:ln>
+        </p:spPr>
+        <p:style>
+          <a:lnRef idx="1">
+            <a:schemeClr val="accent1"/>
+          </a:lnRef>
+          <a:fillRef idx="3">
+            <a:schemeClr val="accent1"/>
+          </a:fillRef>
+          <a:effectRef idx="2">
+            <a:schemeClr val="accent1"/>
+          </a:effectRef>
+          <a:fontRef idx="minor">
+            <a:schemeClr val="lt1"/>
+          </a:fontRef>
+        </p:style>
+        <p:txBody>
+          <a:bodyPr rtlCol="0" anchor="ctr"/>
+          <a:lstStyle/>
+          <a:p>
+            <a:pPr algn="ctr"/>
+          </a:p>
+        </p:txBody>
+      </p:sp>
+      <p:sp>
+        <p:nvSpPr>
+          <p:cNvPr id="6" name="TextBox 5"/>
+          <p:cNvSpPr txBox="1"/>
+          <p:nvPr/>
+        </p:nvSpPr>
+        <p:spPr>
+          <a:xfrm>
+            <a:off x="1051560" y="4480560"/>
+            <a:ext cx="3840480" cy="1737360"/>
+          </a:xfrm>
+          <a:prstGeom prst="rect">
+            <a:avLst/>
+          </a:prstGeom>
+          <a:noFill/>
+        </p:spPr>
+        <p:txBody>
+          <a:bodyPr wrap="square">
+            <a:spAutoFit/>
+          </a:bodyPr>
+          <a:lstStyle/>
+          <a:p>
+            <a:r>
+              <a:rPr sz="1300" b="1">
+                <a:solidFill>
+                  <a:srgbClr val="E63946"/>
+                </a:solidFill>
+                <a:latin typeface="Microsoft JhengHei"/>
+              </a:rPr>
+              <a:t>🚨 麻黃素 ─ 真實禁賽案例</a:t>
+            </a:r>
+          </a:p>
+          <a:p>
+            <a:pPr>
+              <a:spcBef>
+                <a:spcPts val="200"/>
+              </a:spcBef>
+            </a:pPr>
+            <a:r>
+              <a:rPr sz="1150">
+                <a:solidFill>
+                  <a:srgbClr val="1A202C"/>
+                </a:solidFill>
+                <a:latin typeface="Microsoft JhengHei"/>
+              </a:rPr>
+              <a:t>• 台灣網球選手曹家宜 (2025) 於賽前因感冒不適，服用了日本購買的市售非處方感冒藥，因其中含有甲基麻黃鹼成分而在尿檢中呈現陽性，面臨暫時停賽。選手出國參賽切勿自行購買服用任何藥物。</a:t>
+            </a:r>
+          </a:p>
+        </p:txBody>
+      </p:sp>
+      <p:sp>
+        <p:nvSpPr>
+          <p:cNvPr id="7" name="Rectangle 6"/>
+          <p:cNvSpPr/>
+          <p:nvPr/>
+        </p:nvSpPr>
+        <p:spPr>
+          <a:xfrm>
+            <a:off x="6675120" y="1737360"/>
+            <a:ext cx="36576" cy="2926080"/>
           </a:xfrm>
           <a:prstGeom prst="rect">
             <a:avLst/>
@@ -4834,13 +5026,13 @@
       </p:sp>
       <p:sp>
         <p:nvSpPr>
-          <p:cNvPr id="6" name="TextBox 5"/>
+          <p:cNvPr id="8" name="TextBox 7"/>
           <p:cNvSpPr txBox="1"/>
           <p:nvPr/>
         </p:nvSpPr>
         <p:spPr>
           <a:xfrm>
-            <a:off x="5577840" y="1371600"/>
+            <a:off x="5577840" y="1325880"/>
             <a:ext cx="2743200" cy="365760"/>
           </a:xfrm>
           <a:prstGeom prst="rect">
@@ -4849,7 +5041,7 @@
           <a:noFill/>
         </p:spPr>
         <p:txBody>
-          <a:bodyPr wrap="square">
+          <a:bodyPr wrap="none">
             <a:spAutoFit/>
           </a:bodyPr>
           <a:lstStyle/>
@@ -4868,13 +5060,13 @@
       </p:sp>
       <p:sp>
         <p:nvSpPr>
-          <p:cNvPr id="7" name="TextBox 6"/>
+          <p:cNvPr id="9" name="TextBox 8"/>
           <p:cNvSpPr txBox="1"/>
           <p:nvPr/>
         </p:nvSpPr>
         <p:spPr>
           <a:xfrm>
-            <a:off x="5303520" y="1874519"/>
+            <a:off x="5303520" y="1783079"/>
             <a:ext cx="6400800" cy="365760"/>
           </a:xfrm>
           <a:prstGeom prst="rect">
@@ -4889,7 +5081,7 @@
           <a:lstStyle/>
           <a:p>
             <a:pPr>
-              <a:defRPr sz="1200" b="1">
+              <a:defRPr sz="1150" b="1">
                 <a:solidFill>
                   <a:srgbClr val="1A202C"/>
                 </a:solidFill>
@@ -4904,14 +5096,14 @@
       </p:sp>
       <p:sp>
         <p:nvSpPr>
-          <p:cNvPr id="8" name="Rectangle 7"/>
+          <p:cNvPr id="10" name="Rectangle 9"/>
           <p:cNvSpPr/>
           <p:nvPr/>
         </p:nvSpPr>
         <p:spPr>
           <a:xfrm>
-            <a:off x="5303520" y="2194560"/>
-            <a:ext cx="5486400" cy="365760"/>
+            <a:off x="5303520" y="2103120"/>
+            <a:ext cx="5486400" cy="320040"/>
           </a:xfrm>
           <a:prstGeom prst="rect">
             <a:avLst/>
@@ -4949,14 +5141,14 @@
       </p:sp>
       <p:sp>
         <p:nvSpPr>
-          <p:cNvPr id="9" name="Rectangle 8"/>
+          <p:cNvPr id="11" name="Rectangle 10"/>
           <p:cNvSpPr/>
           <p:nvPr/>
         </p:nvSpPr>
         <p:spPr>
           <a:xfrm>
-            <a:off x="5303520" y="2194560"/>
-            <a:ext cx="534924" cy="365760"/>
+            <a:off x="5303520" y="2103120"/>
+            <a:ext cx="534924" cy="320040"/>
           </a:xfrm>
           <a:prstGeom prst="rect">
             <a:avLst/>
@@ -4994,13 +5186,13 @@
       </p:sp>
       <p:sp>
         <p:nvSpPr>
-          <p:cNvPr id="10" name="TextBox 9"/>
+          <p:cNvPr id="12" name="TextBox 11"/>
           <p:cNvSpPr txBox="1"/>
           <p:nvPr/>
         </p:nvSpPr>
         <p:spPr>
           <a:xfrm>
-            <a:off x="5929883" y="2148840"/>
+            <a:off x="5929883" y="2057400"/>
             <a:ext cx="1371600" cy="365760"/>
           </a:xfrm>
           <a:prstGeom prst="rect">
@@ -5015,7 +5207,7 @@
           <a:lstStyle/>
           <a:p>
             <a:pPr>
-              <a:defRPr sz="1200" b="1">
+              <a:defRPr sz="1150" b="1">
                 <a:solidFill>
                   <a:srgbClr val="718096"/>
                 </a:solidFill>
@@ -5030,13 +5222,13 @@
       </p:sp>
       <p:sp>
         <p:nvSpPr>
-          <p:cNvPr id="11" name="TextBox 10"/>
+          <p:cNvPr id="13" name="TextBox 12"/>
           <p:cNvSpPr txBox="1"/>
           <p:nvPr/>
         </p:nvSpPr>
         <p:spPr>
           <a:xfrm>
-            <a:off x="5303520" y="3154679"/>
+            <a:off x="5303520" y="2697479"/>
             <a:ext cx="6400800" cy="365760"/>
           </a:xfrm>
           <a:prstGeom prst="rect">
@@ -5051,7 +5243,7 @@
           <a:lstStyle/>
           <a:p>
             <a:pPr>
-              <a:defRPr sz="1200" b="1">
+              <a:defRPr sz="1150" b="1">
                 <a:solidFill>
                   <a:srgbClr val="1A202C"/>
                 </a:solidFill>
@@ -5059,21 +5251,21 @@
               </a:defRPr>
             </a:pPr>
             <a:r>
-              <a:t>小青龍湯 ─ 連續服用 3 天 (13.73 μg/mL)  ⚠️ 超標 1.3 倍</a:t>
-            </a:r>
-          </a:p>
-        </p:txBody>
-      </p:sp>
-      <p:sp>
-        <p:nvSpPr>
-          <p:cNvPr id="12" name="Rectangle 11"/>
+              <a:t>小青龍湯 ─ 連續服用 3 天 (13.73 μg/mL)  ⚠️ 突破臨界線</a:t>
+            </a:r>
+          </a:p>
+        </p:txBody>
+      </p:sp>
+      <p:sp>
+        <p:nvSpPr>
+          <p:cNvPr id="14" name="Rectangle 13"/>
           <p:cNvSpPr/>
           <p:nvPr/>
         </p:nvSpPr>
         <p:spPr>
           <a:xfrm>
-            <a:off x="5303520" y="3474720"/>
-            <a:ext cx="5486400" cy="365760"/>
+            <a:off x="5303520" y="3017520"/>
+            <a:ext cx="5486400" cy="320040"/>
           </a:xfrm>
           <a:prstGeom prst="rect">
             <a:avLst/>
@@ -5111,14 +5303,14 @@
       </p:sp>
       <p:sp>
         <p:nvSpPr>
-          <p:cNvPr id="13" name="Rectangle 12"/>
+          <p:cNvPr id="15" name="Rectangle 14"/>
           <p:cNvSpPr/>
           <p:nvPr/>
         </p:nvSpPr>
         <p:spPr>
           <a:xfrm>
-            <a:off x="5303520" y="3474720"/>
-            <a:ext cx="1883206" cy="365760"/>
+            <a:off x="5303520" y="3017520"/>
+            <a:ext cx="1883206" cy="320040"/>
           </a:xfrm>
           <a:prstGeom prst="rect">
             <a:avLst/>
@@ -5156,13 +5348,13 @@
       </p:sp>
       <p:sp>
         <p:nvSpPr>
-          <p:cNvPr id="14" name="TextBox 13"/>
+          <p:cNvPr id="16" name="TextBox 15"/>
           <p:cNvSpPr txBox="1"/>
           <p:nvPr/>
         </p:nvSpPr>
         <p:spPr>
           <a:xfrm>
-            <a:off x="7278166" y="3429000"/>
+            <a:off x="7278166" y="2971800"/>
             <a:ext cx="1371600" cy="365760"/>
           </a:xfrm>
           <a:prstGeom prst="rect">
@@ -5177,7 +5369,7 @@
           <a:lstStyle/>
           <a:p>
             <a:pPr>
-              <a:defRPr sz="1200" b="1">
+              <a:defRPr sz="1150" b="1">
                 <a:solidFill>
                   <a:srgbClr val="E63946"/>
                 </a:solidFill>
@@ -5192,13 +5384,13 @@
       </p:sp>
       <p:sp>
         <p:nvSpPr>
-          <p:cNvPr id="15" name="TextBox 14"/>
+          <p:cNvPr id="17" name="TextBox 16"/>
           <p:cNvSpPr txBox="1"/>
           <p:nvPr/>
         </p:nvSpPr>
         <p:spPr>
           <a:xfrm>
-            <a:off x="5303520" y="4434840"/>
+            <a:off x="5303520" y="3611879"/>
             <a:ext cx="6400800" cy="365760"/>
           </a:xfrm>
           <a:prstGeom prst="rect">
@@ -5213,7 +5405,7 @@
           <a:lstStyle/>
           <a:p>
             <a:pPr>
-              <a:defRPr sz="1200" b="1">
+              <a:defRPr sz="1150" b="1">
                 <a:solidFill>
                   <a:srgbClr val="1A202C"/>
                 </a:solidFill>
@@ -5228,14 +5420,14 @@
       </p:sp>
       <p:sp>
         <p:nvSpPr>
-          <p:cNvPr id="16" name="Rectangle 15"/>
+          <p:cNvPr id="18" name="Rectangle 17"/>
           <p:cNvSpPr/>
           <p:nvPr/>
         </p:nvSpPr>
         <p:spPr>
           <a:xfrm>
-            <a:off x="5303520" y="4754880"/>
-            <a:ext cx="5486400" cy="365760"/>
+            <a:off x="5303520" y="3931920"/>
+            <a:ext cx="5486400" cy="320040"/>
           </a:xfrm>
           <a:prstGeom prst="rect">
             <a:avLst/>
@@ -5273,14 +5465,14 @@
       </p:sp>
       <p:sp>
         <p:nvSpPr>
-          <p:cNvPr id="17" name="Rectangle 16"/>
+          <p:cNvPr id="19" name="Rectangle 18"/>
           <p:cNvSpPr/>
           <p:nvPr/>
         </p:nvSpPr>
         <p:spPr>
           <a:xfrm>
-            <a:off x="5303520" y="4754880"/>
-            <a:ext cx="5353354" cy="365760"/>
+            <a:off x="5303520" y="3931920"/>
+            <a:ext cx="5353354" cy="320040"/>
           </a:xfrm>
           <a:prstGeom prst="rect">
             <a:avLst/>
@@ -5318,13 +5510,13 @@
       </p:sp>
       <p:sp>
         <p:nvSpPr>
-          <p:cNvPr id="18" name="TextBox 17"/>
+          <p:cNvPr id="20" name="TextBox 19"/>
           <p:cNvSpPr txBox="1"/>
           <p:nvPr/>
         </p:nvSpPr>
         <p:spPr>
           <a:xfrm>
-            <a:off x="10748314" y="4709160"/>
+            <a:off x="10748314" y="3886200"/>
             <a:ext cx="1371600" cy="365760"/>
           </a:xfrm>
           <a:prstGeom prst="rect">
@@ -5339,7 +5531,7 @@
           <a:lstStyle/>
           <a:p>
             <a:pPr>
-              <a:defRPr sz="1200" b="1">
+              <a:defRPr sz="1150" b="1">
                 <a:solidFill>
                   <a:srgbClr val="B91C1C"/>
                 </a:solidFill>
@@ -5348,6 +5540,104 @@
             </a:pPr>
             <a:r>
               <a:t>39.03 μg/mL</a:t>
+            </a:r>
+          </a:p>
+        </p:txBody>
+      </p:sp>
+      <p:sp>
+        <p:nvSpPr>
+          <p:cNvPr id="21" name="Rounded Rectangle 20"/>
+          <p:cNvSpPr/>
+          <p:nvPr/>
+        </p:nvSpPr>
+        <p:spPr>
+          <a:xfrm>
+            <a:off x="5303520" y="4846320"/>
+            <a:ext cx="5943600" cy="1463040"/>
+          </a:xfrm>
+          <a:prstGeom prst="roundRect">
+            <a:avLst/>
+          </a:prstGeom>
+          <a:solidFill>
+            <a:srgbClr val="E0F2FE"/>
+          </a:solidFill>
+          <a:ln w="15240">
+            <a:solidFill>
+              <a:srgbClr val="BAE6FD"/>
+            </a:solidFill>
+          </a:ln>
+        </p:spPr>
+        <p:style>
+          <a:lnRef idx="1">
+            <a:schemeClr val="accent1"/>
+          </a:lnRef>
+          <a:fillRef idx="3">
+            <a:schemeClr val="accent1"/>
+          </a:fillRef>
+          <a:effectRef idx="2">
+            <a:schemeClr val="accent1"/>
+          </a:effectRef>
+          <a:fontRef idx="minor">
+            <a:schemeClr val="lt1"/>
+          </a:fontRef>
+        </p:style>
+        <p:txBody>
+          <a:bodyPr rtlCol="0" anchor="ctr"/>
+          <a:lstStyle/>
+          <a:p>
+            <a:pPr algn="ctr"/>
+          </a:p>
+        </p:txBody>
+      </p:sp>
+      <p:sp>
+        <p:nvSpPr>
+          <p:cNvPr id="22" name="TextBox 21"/>
+          <p:cNvSpPr txBox="1"/>
+          <p:nvPr/>
+        </p:nvSpPr>
+        <p:spPr>
+          <a:xfrm>
+            <a:off x="5440680" y="4937760"/>
+            <a:ext cx="5669280" cy="1280160"/>
+          </a:xfrm>
+          <a:prstGeom prst="rect">
+            <a:avLst/>
+          </a:prstGeom>
+          <a:noFill/>
+        </p:spPr>
+        <p:txBody>
+          <a:bodyPr wrap="square">
+            <a:spAutoFit/>
+          </a:bodyPr>
+          <a:lstStyle/>
+          <a:p>
+            <a:r>
+              <a:rPr sz="1300" b="1">
+                <a:solidFill>
+                  <a:srgbClr val="005F73"/>
+                </a:solidFill>
+                <a:latin typeface="Microsoft JhengHei"/>
+              </a:rPr>
+              <a:t>🟢 運動員安全中藥替代方案</a:t>
+            </a:r>
+          </a:p>
+          <a:p>
+            <a:pPr>
+              <a:spcBef>
+                <a:spcPts val="200"/>
+              </a:spcBef>
+            </a:pPr>
+            <a:r>
+              <a:rPr sz="1150">
+                <a:solidFill>
+                  <a:srgbClr val="1A202C"/>
+                </a:solidFill>
+                <a:latin typeface="Microsoft JhengHei"/>
+              </a:rPr>
+              <a:t>• 葛根湯 ➔ 桂枝湯 / 銀花散 (適用感冒初期項背酸痛，不含麻黃)
+• 小青龍湯 ➔ 止嗽散 / 二陳湯 (適用咳嗽化痰，安全性高)
+• 麻杏甘石湯 ➔ 桑菊飲 / 清肺湯 (適用熱邪喘咳，無禁用興奮劑)
+* 停藥建議：若服用了含麻黃之中藥，賽前至少 7~10 天（保守 2 週）須停藥。</a:t>
             </a:r>
           </a:p>
         </p:txBody>
@@ -5956,8 +6246,8 @@
         </p:nvSpPr>
         <p:spPr>
           <a:xfrm>
-            <a:off x="914400" y="1645920"/>
-            <a:ext cx="4572000" cy="1645920"/>
+            <a:off x="914400" y="1371600"/>
+            <a:ext cx="4572000" cy="1097280"/>
           </a:xfrm>
           <a:prstGeom prst="rect">
             <a:avLst/>
@@ -5971,7 +6261,7 @@
           <a:lstStyle/>
           <a:p>
             <a:r>
-              <a:rPr sz="6400" b="1">
+              <a:rPr sz="5600" b="1">
                 <a:solidFill>
                   <a:srgbClr val="E63946"/>
                 </a:solidFill>
@@ -5982,13 +6272,13 @@
           </a:p>
           <a:p>
             <a:r>
-              <a:rPr sz="1600" b="1">
+              <a:rPr sz="1400" b="1">
                 <a:solidFill>
                   <a:srgbClr val="1A202C"/>
                 </a:solidFill>
                 <a:latin typeface="Microsoft JhengHei"/>
               </a:rPr>
-              <a:t>全球膳食補充劑與草本顆粒之非法摻假率</a:t>
+              <a:t>全球膳食補充劑與草本製品之非法摻假率</a:t>
             </a:r>
           </a:p>
         </p:txBody>
@@ -6001,8 +6291,8 @@
         </p:nvSpPr>
         <p:spPr>
           <a:xfrm>
-            <a:off x="914400" y="3383280"/>
-            <a:ext cx="4572000" cy="2560320"/>
+            <a:off x="914400" y="2651760"/>
+            <a:ext cx="4572000" cy="2011680"/>
           </a:xfrm>
           <a:prstGeom prst="roundRect">
             <a:avLst/>
@@ -6046,8 +6336,190 @@
         </p:nvSpPr>
         <p:spPr>
           <a:xfrm>
-            <a:off x="1051560" y="3520440"/>
-            <a:ext cx="4297680" cy="2286000"/>
+            <a:off x="1051560" y="2743200"/>
+            <a:ext cx="4297680" cy="1828800"/>
+          </a:xfrm>
+          <a:prstGeom prst="rect">
+            <a:avLst/>
+          </a:prstGeom>
+          <a:noFill/>
+        </p:spPr>
+        <p:txBody>
+          <a:bodyPr wrap="square">
+            <a:spAutoFit/>
+          </a:bodyPr>
+          <a:lstStyle/>
+          <a:p>
+            <a:r>
+              <a:rPr sz="1400" b="1">
+                <a:solidFill>
+                  <a:srgbClr val="E63946"/>
+                </a:solidFill>
+                <a:latin typeface="Microsoft JhengHei"/>
+              </a:rPr>
+              <a:t>💡 數據實體化對比 (Real-world Analogy)
+</a:t>
+            </a:r>
+          </a:p>
+          <a:p>
+            <a:pPr>
+              <a:spcBef>
+                <a:spcPts val="400"/>
+              </a:spcBef>
+            </a:pPr>
+            <a:r>
+              <a:rPr sz="1300">
+                <a:solidFill>
+                  <a:srgbClr val="1A202C"/>
+                </a:solidFill>
+                <a:latin typeface="Microsoft JhengHei"/>
+              </a:rPr>
+              <a:t>每 </a:t>
+            </a:r>
+            <a:r>
+              <a:rPr sz="1400" b="1">
+                <a:solidFill>
+                  <a:srgbClr val="E63946"/>
+                </a:solidFill>
+                <a:latin typeface="Microsoft JhengHei"/>
+              </a:rPr>
+              <a:t>10 瓶</a:t>
+            </a:r>
+            <a:r>
+              <a:rPr sz="1300">
+                <a:solidFill>
+                  <a:srgbClr val="1A202C"/>
+                </a:solidFill>
+                <a:latin typeface="Microsoft JhengHei"/>
+              </a:rPr>
+              <a:t>標榜純天然無添加的草本膳食補充劑中，就有 </a:t>
+            </a:r>
+            <a:r>
+              <a:rPr sz="1400" b="1">
+                <a:solidFill>
+                  <a:srgbClr val="E63946"/>
+                </a:solidFill>
+                <a:latin typeface="Microsoft JhengHei"/>
+              </a:rPr>
+              <a:t>1 瓶以上</a:t>
+            </a:r>
+            <a:r>
+              <a:rPr sz="1300">
+                <a:solidFill>
+                  <a:srgbClr val="1A202C"/>
+                </a:solidFill>
+                <a:latin typeface="Microsoft JhengHei"/>
+              </a:rPr>
+              <a:t>摻雜有未標示的禁藥化學物質（如 SARM、合成類固醇與興奮劑）。</a:t>
+            </a:r>
+          </a:p>
+        </p:txBody>
+      </p:sp>
+      <p:sp>
+        <p:nvSpPr>
+          <p:cNvPr id="7" name="Rounded Rectangle 6"/>
+          <p:cNvSpPr/>
+          <p:nvPr/>
+        </p:nvSpPr>
+        <p:spPr>
+          <a:xfrm>
+            <a:off x="914400" y="4846320"/>
+            <a:ext cx="4572000" cy="1463040"/>
+          </a:xfrm>
+          <a:prstGeom prst="roundRect">
+            <a:avLst/>
+          </a:prstGeom>
+          <a:solidFill>
+            <a:srgbClr val="FED7D7"/>
+          </a:solidFill>
+          <a:ln w="15240">
+            <a:solidFill>
+              <a:srgbClr val="E63946"/>
+            </a:solidFill>
+          </a:ln>
+        </p:spPr>
+        <p:style>
+          <a:lnRef idx="1">
+            <a:schemeClr val="accent1"/>
+          </a:lnRef>
+          <a:fillRef idx="3">
+            <a:schemeClr val="accent1"/>
+          </a:fillRef>
+          <a:effectRef idx="2">
+            <a:schemeClr val="accent1"/>
+          </a:effectRef>
+          <a:fontRef idx="minor">
+            <a:schemeClr val="lt1"/>
+          </a:fontRef>
+        </p:style>
+        <p:txBody>
+          <a:bodyPr rtlCol="0" anchor="ctr"/>
+          <a:lstStyle/>
+          <a:p>
+            <a:pPr algn="ctr"/>
+          </a:p>
+        </p:txBody>
+      </p:sp>
+      <p:sp>
+        <p:nvSpPr>
+          <p:cNvPr id="8" name="TextBox 7"/>
+          <p:cNvSpPr txBox="1"/>
+          <p:nvPr/>
+        </p:nvSpPr>
+        <p:spPr>
+          <a:xfrm>
+            <a:off x="1051560" y="4937760"/>
+            <a:ext cx="4297680" cy="1280160"/>
+          </a:xfrm>
+          <a:prstGeom prst="rect">
+            <a:avLst/>
+          </a:prstGeom>
+          <a:noFill/>
+        </p:spPr>
+        <p:txBody>
+          <a:bodyPr wrap="square">
+            <a:spAutoFit/>
+          </a:bodyPr>
+          <a:lstStyle/>
+          <a:p>
+            <a:r>
+              <a:rPr sz="1300" b="1">
+                <a:solidFill>
+                  <a:srgbClr val="E63946"/>
+                </a:solidFill>
+                <a:latin typeface="Microsoft JhengHei"/>
+              </a:rPr>
+              <a:t>🚨 補充劑污染 ─ 真實禁賽案例</a:t>
+            </a:r>
+          </a:p>
+          <a:p>
+            <a:pPr>
+              <a:spcBef>
+                <a:spcPts val="200"/>
+              </a:spcBef>
+            </a:pPr>
+            <a:r>
+              <a:rPr sz="1150">
+                <a:solidFill>
+                  <a:srgbClr val="1A202C"/>
+                </a:solidFill>
+                <a:latin typeface="Microsoft JhengHei"/>
+              </a:rPr>
+              <a:t>• 美國舉重選手 Matthew McCullough (2019) 服用一款標榜「全天然」提神補充劑，被驗出去甲烏藥鹼與瘦肉精 (Clenbuterol)，證實產品遭交叉污染，被判禁賽 20 個月。</a:t>
+            </a:r>
+          </a:p>
+        </p:txBody>
+      </p:sp>
+      <p:sp>
+        <p:nvSpPr>
+          <p:cNvPr id="9" name="TextBox 8"/>
+          <p:cNvSpPr txBox="1"/>
+          <p:nvPr/>
+        </p:nvSpPr>
+        <p:spPr>
+          <a:xfrm>
+            <a:off x="5852160" y="1371600"/>
+            <a:ext cx="5394960" cy="4937760"/>
           </a:xfrm>
           <a:prstGeom prst="rect">
             <a:avLst/>
@@ -6066,160 +6538,77 @@
               </a:spcAft>
             </a:pPr>
             <a:r>
-              <a:rPr sz="1600" b="1">
-                <a:solidFill>
-                  <a:srgbClr val="E63946"/>
-                </a:solidFill>
-                <a:latin typeface="Microsoft JhengHei"/>
-              </a:rPr>
-              <a:t>💡 數據實體化對比 (Real-world Analogy)</a:t>
-            </a:r>
-          </a:p>
-          <a:p>
-            <a:r>
-              <a:rPr sz="1400">
-                <a:solidFill>
-                  <a:srgbClr val="1A202C"/>
-                </a:solidFill>
-                <a:latin typeface="Microsoft JhengHei"/>
-              </a:rPr>
-              <a:t>每 </a:t>
-            </a:r>
-            <a:r>
-              <a:rPr sz="1500" b="1">
-                <a:solidFill>
-                  <a:srgbClr val="E63946"/>
-                </a:solidFill>
-                <a:latin typeface="Microsoft JhengHei"/>
-              </a:rPr>
-              <a:t>10 瓶</a:t>
-            </a:r>
-            <a:r>
-              <a:rPr sz="1400">
-                <a:solidFill>
-                  <a:srgbClr val="1A202C"/>
-                </a:solidFill>
-                <a:latin typeface="Microsoft JhengHei"/>
-              </a:rPr>
-              <a:t>標榜「純天然、無添加」的草本膳食補充劑中，就有 </a:t>
-            </a:r>
-            <a:r>
-              <a:rPr sz="1500" b="1">
-                <a:solidFill>
-                  <a:srgbClr val="E63946"/>
-                </a:solidFill>
-                <a:latin typeface="Microsoft JhengHei"/>
-              </a:rPr>
-              <a:t>1 瓶以上</a:t>
-            </a:r>
-            <a:r>
-              <a:rPr sz="1400">
-                <a:solidFill>
-                  <a:srgbClr val="1A202C"/>
-                </a:solidFill>
-                <a:latin typeface="Microsoft JhengHei"/>
-              </a:rPr>
-              <a:t>被檢出含有 WADA 禁用之化學成分（如 SARMs、合成類固醇或合成興奮劑），標籤上完全未標示！</a:t>
-            </a:r>
-          </a:p>
-        </p:txBody>
-      </p:sp>
-      <p:sp>
-        <p:nvSpPr>
-          <p:cNvPr id="7" name="TextBox 6"/>
-          <p:cNvSpPr txBox="1"/>
-          <p:nvPr/>
-        </p:nvSpPr>
-        <p:spPr>
-          <a:xfrm>
-            <a:off x="5943600" y="1645920"/>
-            <a:ext cx="5303520" cy="4297680"/>
-          </a:xfrm>
-          <a:prstGeom prst="rect">
-            <a:avLst/>
-          </a:prstGeom>
-          <a:noFill/>
-        </p:spPr>
-        <p:txBody>
-          <a:bodyPr wrap="square">
-            <a:spAutoFit/>
-          </a:bodyPr>
-          <a:lstStyle/>
+              <a:rPr sz="1800" b="1">
+                <a:solidFill>
+                  <a:srgbClr val="005F73"/>
+                </a:solidFill>
+                <a:latin typeface="Microsoft JhengHei"/>
+              </a:rPr>
+              <a:t>🩸 生物護照 (ABP) 的血液學干擾</a:t>
+            </a:r>
+          </a:p>
           <a:p>
             <a:pPr>
               <a:spcAft>
-                <a:spcPts val="1000"/>
+                <a:spcPts val="1200"/>
               </a:spcAft>
             </a:pPr>
             <a:r>
-              <a:rPr sz="1800" b="1">
-                <a:solidFill>
-                  <a:srgbClr val="005F73"/>
-                </a:solidFill>
-                <a:latin typeface="Microsoft JhengHei"/>
-              </a:rPr>
-              <a:t>🩸 生物護照 (ABP) 的血液學干擾</a:t>
+              <a:rPr sz="1350">
+                <a:solidFill>
+                  <a:srgbClr val="4A5568"/>
+                </a:solidFill>
+                <a:latin typeface="Microsoft JhengHei"/>
+              </a:rPr>
+              <a:t>當歸、黃芪、丹參等補血益氣中藥可刺激骨髓紅血球造血系統。連續服用 14 天後，選手的網狀紅血球百分比 (RET%) 會呈現顯著的生理上升。此生理學波動極易被 ABP 演算法判定為 atypical（異常），被懷疑使用 EPO，進而招致額外審查。</a:t>
             </a:r>
           </a:p>
           <a:p>
             <a:pPr>
+              <a:spcBef>
+                <a:spcPts val="800"/>
+              </a:spcBef>
               <a:spcAft>
-                <a:spcPts val="1400"/>
+                <a:spcPts val="800"/>
               </a:spcAft>
             </a:pPr>
             <a:r>
-              <a:rPr sz="1400">
+              <a:rPr sz="1800" b="1">
+                <a:solidFill>
+                  <a:srgbClr val="005F73"/>
+                </a:solidFill>
+                <a:latin typeface="Microsoft JhengHei"/>
+              </a:rPr>
+              <a:t>⚠️ 臨床專家的認知盲區</a:t>
+            </a:r>
+          </a:p>
+          <a:p>
+            <a:r>
+              <a:rPr sz="1350">
                 <a:solidFill>
                   <a:srgbClr val="4A5568"/>
                 </a:solidFill>
                 <a:latin typeface="Microsoft JhengHei"/>
               </a:rPr>
-              <a:t>當歸、黃芪、丹參等補血益氣中藥可刺激骨髓紅血球造血系統。連續服用 14 天後，選手的網狀紅血球百分比 (RET%) 會顯著升高，易被 WADA 生物護照演算法判定為 atypical（異常），被懷疑使用 EPO，進而招致額外審查。</a:t>
-            </a:r>
-          </a:p>
-          <a:p>
-            <a:pPr>
-              <a:spcAft>
-                <a:spcPts val="1000"/>
-              </a:spcAft>
-            </a:pPr>
-            <a:r>
-              <a:rPr sz="1800" b="1">
-                <a:solidFill>
-                  <a:srgbClr val="005F73"/>
-                </a:solidFill>
-                <a:latin typeface="Microsoft JhengHei"/>
-              </a:rPr>
-              <a:t>⚠️ 臨床專家的認知盲區</a:t>
-            </a:r>
-          </a:p>
-          <a:p>
-            <a:r>
-              <a:rPr sz="1400">
+              <a:t>2025 學術調查發現，超過 </a:t>
+            </a:r>
+            <a:r>
+              <a:rPr sz="1350" b="1">
+                <a:solidFill>
+                  <a:srgbClr val="E63946"/>
+                </a:solidFill>
+                <a:latin typeface="Microsoft JhengHei"/>
+              </a:rPr>
+              <a:t>40% 的臨床醫學與藥學專家</a:t>
+            </a:r>
+            <a:r>
+              <a:rPr sz="1350">
                 <a:solidFill>
                   <a:srgbClr val="4A5568"/>
                 </a:solidFill>
                 <a:latin typeface="Microsoft JhengHei"/>
               </a:rPr>
-              <a:t>2025 學術調查發現，超過 </a:t>
-            </a:r>
-            <a:r>
-              <a:rPr sz="1400" b="1">
-                <a:solidFill>
-                  <a:srgbClr val="E63946"/>
-                </a:solidFill>
-                <a:latin typeface="Microsoft JhengHei"/>
-              </a:rPr>
-              <a:t>40% 的臨床醫學與藥學專家</a:t>
-            </a:r>
-            <a:r>
-              <a:rPr sz="1400">
-                <a:solidFill>
-                  <a:srgbClr val="4A5568"/>
-                </a:solidFill>
-                <a:latin typeface="Microsoft JhengHei"/>
-              </a:rPr>
-              <a:t>並不清楚「去甲烏藥鹼」是運動禁用物質，這意味著如果沒有接受過禁藥管制培訓的中醫師開藥，選手極易誤服而觸網。</a:t>
+              <a:t>並不清楚去甲烏藥鹼是運動禁用物質，非專科就醫極易誤服，防制教育宣導極其重要。</a:t>
             </a:r>
           </a:p>
         </p:txBody>

</xml_diff>